<commit_message>
Pitch v2: hinna põhjendus slaidil 2, demo video 49 s, märkmete ajad
Co-Authored-By: Claude Opus 5.5 <noreply@anthropic.com>
Claude-Session: https://claude.ai/code/session_01UQ9XEDkLAzZr24mHniFE57
</commit_message>
<xml_diff>
--- a/esitlus/tuleva-kogum-pitch-v2.pptx
+++ b/esitlus/tuleva-kogum-pitch-v2.pptx
@@ -2178,10 +2178,20 @@
           <a:lstStyle/>
           <a:p>
             <a:r>
-              <a:rPr lang="en-US" dirty="0"/>
-              <a:t>0:15–0:40 (≈55 sõna)
-Kadri on 38. Ta helistas operaatorile, kauples ja sai piiramatu paketi 15,50 euroga. Aga ainult 24 kuuks. 25. kuul on arve 34,99, see on 126% rohkem, ja ring algab otsast. Võrdlusportaal teda ei aita, sest teenib operaatori vahendustasust. Üksi pole Kadril läbirääkimisjõudu. Tuhandel inimesel on.
-Küsimuseks: liikmeküsitluses (13.04–03.05.2026, 5 014 vastajat) pidas 83% püsikulusid probleemiks. Eestis on 1,8 mln lepingulist mobiilikasutajat (TTJA 2025).</a:t>
+              <a:t>0:15–0:40 (≈55 sõna)</a:t>
+            </a:r>
+          </a:p>
+          <a:p>
+            <a:r>
+              <a:t>Kadri on 38. Ta helistas operaatorile, kauples ja sai piiramatu paketi 15,50 euroga. Aga ainult 24 kuuks. 25. kuul on arve 34,99, see on 126% rohkem, ja ring algab otsast. Võrdlusportaal teda ei aita, sest teenib operaatori vahendustasust. Üksi pole Kadril läbirääkimisjõudu. Tuhandel inimesel on. Sellepärast on Kogumi hind madal: tuhat inimest küsib korraga ja keegi ei teeni sellest, et sa üle maksad.</a:t>
+            </a:r>
+          </a:p>
+          <a:p>
+            <a:endParaRPr/>
+          </a:p>
+          <a:p>
+            <a:r>
+              <a:t>Küsimuseks: liikmeküsitluses (13.04–03.05.2026, 5 014 vastajat) pidas 83% püsikulusid probleemiks. Eestis on 1,8 mln lepingulist mobiilikasutajat (TTJA 2025).</a:t>
             </a:r>
           </a:p>
         </p:txBody>
@@ -3744,20 +3754,278 @@
           <a:lstStyle/>
           <a:p>
             <a:r>
-              <a:t>2:47–3:00 (≈40 sõna)</a:t>
-            </a:r>
-          </a:p>
-          <a:p>
-            <a:r>
-              <a:t>Järgmised sammud: avame registreerumise Tuleva kogukonnas, saadame hankepäringu kõigile operaatoritele ja teeme esimese hanke käsitsi. Selleks vajame Tuleva otsust ja ühte inimest, õigus- ja andmekaitseanalüüsi ning kontakti operaatoritega. Üksi pole sul läbirääkimisjõudu. Tuhandel inimesel on.</a:t>
-            </a:r>
-          </a:p>
-          <a:p>
-            <a:endParaRPr/>
-          </a:p>
-          <a:p>
-            <a:r>
-              <a:t>Jäta see slaid küsimuste ajaks ekraanile.</a:t>
+              <a:rPr dirty="0"/>
+              <a:t>2:47–3:00 (≈40 </a:t>
+            </a:r>
+            <a:r>
+              <a:rPr dirty="0" err="1"/>
+              <a:t>sõna</a:t>
+            </a:r>
+            <a:r>
+              <a:rPr dirty="0"/>
+              <a:t>)</a:t>
+            </a:r>
+          </a:p>
+          <a:p>
+            <a:r>
+              <a:rPr dirty="0" err="1"/>
+              <a:t>Järgmised</a:t>
+            </a:r>
+            <a:r>
+              <a:rPr dirty="0"/>
+              <a:t> </a:t>
+            </a:r>
+            <a:r>
+              <a:rPr dirty="0" err="1"/>
+              <a:t>sammud</a:t>
+            </a:r>
+            <a:r>
+              <a:rPr dirty="0"/>
+              <a:t>: </a:t>
+            </a:r>
+            <a:r>
+              <a:rPr dirty="0" err="1"/>
+              <a:t>avame</a:t>
+            </a:r>
+            <a:r>
+              <a:rPr dirty="0"/>
+              <a:t> </a:t>
+            </a:r>
+            <a:r>
+              <a:rPr dirty="0" err="1"/>
+              <a:t>registreerumise</a:t>
+            </a:r>
+            <a:r>
+              <a:rPr dirty="0"/>
+              <a:t> Tuleva </a:t>
+            </a:r>
+            <a:r>
+              <a:rPr dirty="0" err="1"/>
+              <a:t>kogukonnas</a:t>
+            </a:r>
+            <a:r>
+              <a:rPr dirty="0"/>
+              <a:t>, </a:t>
+            </a:r>
+            <a:r>
+              <a:rPr dirty="0" err="1"/>
+              <a:t>saadame</a:t>
+            </a:r>
+            <a:r>
+              <a:rPr dirty="0"/>
+              <a:t> </a:t>
+            </a:r>
+            <a:r>
+              <a:rPr dirty="0" err="1"/>
+              <a:t>hankepäringu</a:t>
+            </a:r>
+            <a:r>
+              <a:rPr dirty="0"/>
+              <a:t> </a:t>
+            </a:r>
+            <a:r>
+              <a:rPr dirty="0" err="1"/>
+              <a:t>kõigile</a:t>
+            </a:r>
+            <a:r>
+              <a:rPr dirty="0"/>
+              <a:t> </a:t>
+            </a:r>
+            <a:r>
+              <a:rPr dirty="0" err="1"/>
+              <a:t>operaatoritele</a:t>
+            </a:r>
+            <a:r>
+              <a:rPr dirty="0"/>
+              <a:t> ja </a:t>
+            </a:r>
+            <a:r>
+              <a:rPr dirty="0" err="1"/>
+              <a:t>teeme</a:t>
+            </a:r>
+            <a:r>
+              <a:rPr dirty="0"/>
+              <a:t> </a:t>
+            </a:r>
+            <a:r>
+              <a:rPr dirty="0" err="1"/>
+              <a:t>esimese</a:t>
+            </a:r>
+            <a:r>
+              <a:rPr dirty="0"/>
+              <a:t> </a:t>
+            </a:r>
+            <a:r>
+              <a:rPr dirty="0" err="1"/>
+              <a:t>hanke</a:t>
+            </a:r>
+            <a:r>
+              <a:rPr dirty="0"/>
+              <a:t> </a:t>
+            </a:r>
+            <a:r>
+              <a:rPr dirty="0" err="1"/>
+              <a:t>käsitsi</a:t>
+            </a:r>
+            <a:r>
+              <a:rPr dirty="0"/>
+              <a:t>. </a:t>
+            </a:r>
+            <a:r>
+              <a:rPr dirty="0" err="1"/>
+              <a:t>Selleks</a:t>
+            </a:r>
+            <a:r>
+              <a:rPr dirty="0"/>
+              <a:t> </a:t>
+            </a:r>
+            <a:r>
+              <a:rPr dirty="0" err="1"/>
+              <a:t>vajame</a:t>
+            </a:r>
+            <a:r>
+              <a:rPr dirty="0"/>
+              <a:t> Tuleva </a:t>
+            </a:r>
+            <a:r>
+              <a:rPr dirty="0" err="1"/>
+              <a:t>otsust</a:t>
+            </a:r>
+            <a:r>
+              <a:rPr dirty="0"/>
+              <a:t> ja </a:t>
+            </a:r>
+            <a:r>
+              <a:rPr dirty="0" err="1"/>
+              <a:t>ühte</a:t>
+            </a:r>
+            <a:r>
+              <a:rPr dirty="0"/>
+              <a:t> </a:t>
+            </a:r>
+            <a:r>
+              <a:rPr dirty="0" err="1"/>
+              <a:t>inimest</a:t>
+            </a:r>
+            <a:r>
+              <a:rPr dirty="0"/>
+              <a:t>, </a:t>
+            </a:r>
+            <a:r>
+              <a:rPr dirty="0" err="1"/>
+              <a:t>õigus</a:t>
+            </a:r>
+            <a:r>
+              <a:rPr dirty="0"/>
+              <a:t>- ja </a:t>
+            </a:r>
+            <a:r>
+              <a:rPr dirty="0" err="1"/>
+              <a:t>andmekaitseanalüüsi</a:t>
+            </a:r>
+            <a:r>
+              <a:rPr dirty="0"/>
+              <a:t> </a:t>
+            </a:r>
+            <a:r>
+              <a:rPr dirty="0" err="1"/>
+              <a:t>ning</a:t>
+            </a:r>
+            <a:r>
+              <a:rPr dirty="0"/>
+              <a:t> </a:t>
+            </a:r>
+            <a:r>
+              <a:rPr dirty="0" err="1"/>
+              <a:t>kontakti</a:t>
+            </a:r>
+            <a:r>
+              <a:rPr dirty="0"/>
+              <a:t> </a:t>
+            </a:r>
+            <a:r>
+              <a:rPr dirty="0" err="1"/>
+              <a:t>operaatoritega</a:t>
+            </a:r>
+            <a:r>
+              <a:rPr dirty="0"/>
+              <a:t>. </a:t>
+            </a:r>
+            <a:r>
+              <a:rPr dirty="0" err="1"/>
+              <a:t>Üksi</a:t>
+            </a:r>
+            <a:r>
+              <a:rPr dirty="0"/>
+              <a:t> pole </a:t>
+            </a:r>
+            <a:r>
+              <a:rPr dirty="0" err="1"/>
+              <a:t>sul</a:t>
+            </a:r>
+            <a:r>
+              <a:rPr dirty="0"/>
+              <a:t> </a:t>
+            </a:r>
+            <a:r>
+              <a:rPr dirty="0" err="1"/>
+              <a:t>läbirääkimisjõudu</a:t>
+            </a:r>
+            <a:r>
+              <a:rPr dirty="0"/>
+              <a:t>. </a:t>
+            </a:r>
+            <a:r>
+              <a:rPr dirty="0" err="1"/>
+              <a:t>Tuhandel</a:t>
+            </a:r>
+            <a:r>
+              <a:rPr dirty="0"/>
+              <a:t> </a:t>
+            </a:r>
+            <a:r>
+              <a:rPr dirty="0" err="1"/>
+              <a:t>inimesel</a:t>
+            </a:r>
+            <a:r>
+              <a:t> on.</a:t>
+            </a:r>
+          </a:p>
+          <a:p>
+            <a:endParaRPr dirty="0"/>
+          </a:p>
+          <a:p>
+            <a:r>
+              <a:rPr dirty="0" err="1"/>
+              <a:t>Jäta</a:t>
+            </a:r>
+            <a:r>
+              <a:rPr dirty="0"/>
+              <a:t> see slaid </a:t>
+            </a:r>
+            <a:r>
+              <a:rPr dirty="0" err="1"/>
+              <a:t>küsimuste</a:t>
+            </a:r>
+            <a:r>
+              <a:rPr dirty="0"/>
+              <a:t> </a:t>
+            </a:r>
+            <a:r>
+              <a:rPr dirty="0" err="1"/>
+              <a:t>ajaks</a:t>
+            </a:r>
+            <a:r>
+              <a:rPr dirty="0"/>
+              <a:t> </a:t>
+            </a:r>
+            <a:r>
+              <a:rPr dirty="0" err="1"/>
+              <a:t>ekraanile</a:t>
+            </a:r>
+            <a:r>
+              <a:rPr dirty="0"/>
+              <a:t>.</a:t>
             </a:r>
           </a:p>
         </p:txBody>
@@ -4288,7 +4556,7 @@
           </a:prstGeom>
           <a:extLst>
             <a:ext uri="{C572A759-6A51-4108-AA02-DFA0A04FC94B}">
-              <ma14:wrappingTextBoxFlag xmlns:ma14="http://schemas.microsoft.com/office/mac/drawingml/2011/main" xmlns="" val="0"/>
+              <ma14:wrappingTextBoxFlag xmlns="" xmlns:ma14="http://schemas.microsoft.com/office/mac/drawingml/2011/main" val="0"/>
             </a:ext>
           </a:extLst>
         </p:spPr>
@@ -4517,7 +4785,7 @@
           </a:prstGeom>
           <a:extLst>
             <a:ext uri="{C572A759-6A51-4108-AA02-DFA0A04FC94B}">
-              <ma14:wrappingTextBoxFlag xmlns:ma14="http://schemas.microsoft.com/office/mac/drawingml/2011/main" xmlns="" val="0"/>
+              <ma14:wrappingTextBoxFlag xmlns="" xmlns:ma14="http://schemas.microsoft.com/office/mac/drawingml/2011/main" val="0"/>
             </a:ext>
           </a:extLst>
         </p:spPr>
@@ -4592,7 +4860,7 @@
           </a:prstGeom>
           <a:extLst>
             <a:ext uri="{C572A759-6A51-4108-AA02-DFA0A04FC94B}">
-              <ma14:wrappingTextBoxFlag xmlns:ma14="http://schemas.microsoft.com/office/mac/drawingml/2011/main" xmlns="" val="0"/>
+              <ma14:wrappingTextBoxFlag xmlns="" xmlns:ma14="http://schemas.microsoft.com/office/mac/drawingml/2011/main" val="0"/>
             </a:ext>
           </a:extLst>
         </p:spPr>
@@ -5308,7 +5576,7 @@
           </a:prstGeom>
           <a:extLst>
             <a:ext uri="{C572A759-6A51-4108-AA02-DFA0A04FC94B}">
-              <ma14:wrappingTextBoxFlag xmlns:ma14="http://schemas.microsoft.com/office/mac/drawingml/2011/main" xmlns="" val="0"/>
+              <ma14:wrappingTextBoxFlag xmlns="" xmlns:ma14="http://schemas.microsoft.com/office/mac/drawingml/2011/main" val="0"/>
             </a:ext>
           </a:extLst>
         </p:spPr>
@@ -6610,7 +6878,7 @@
           </a:prstGeom>
           <a:extLst>
             <a:ext uri="{C572A759-6A51-4108-AA02-DFA0A04FC94B}">
-              <ma14:wrappingTextBoxFlag xmlns:ma14="http://schemas.microsoft.com/office/mac/drawingml/2011/main" xmlns="" val="0"/>
+              <ma14:wrappingTextBoxFlag xmlns="" xmlns:ma14="http://schemas.microsoft.com/office/mac/drawingml/2011/main" val="0"/>
             </a:ext>
           </a:extLst>
         </p:spPr>
@@ -7157,7 +7425,7 @@
           </a:prstGeom>
           <a:extLst>
             <a:ext uri="{C572A759-6A51-4108-AA02-DFA0A04FC94B}">
-              <ma14:wrappingTextBoxFlag xmlns:ma14="http://schemas.microsoft.com/office/mac/drawingml/2011/main" xmlns="" val="0"/>
+              <ma14:wrappingTextBoxFlag xmlns="" xmlns:ma14="http://schemas.microsoft.com/office/mac/drawingml/2011/main" val="0"/>
             </a:ext>
           </a:extLst>
         </p:spPr>
@@ -8177,7 +8445,7 @@
           </a:prstGeom>
           <a:extLst>
             <a:ext uri="{C572A759-6A51-4108-AA02-DFA0A04FC94B}">
-              <ma14:wrappingTextBoxFlag xmlns:ma14="http://schemas.microsoft.com/office/mac/drawingml/2011/main" xmlns="" val="0"/>
+              <ma14:wrappingTextBoxFlag xmlns="" xmlns:ma14="http://schemas.microsoft.com/office/mac/drawingml/2011/main" val="0"/>
             </a:ext>
           </a:extLst>
         </p:spPr>
@@ -8533,7 +8801,7 @@
           </a:prstGeom>
           <a:extLst>
             <a:ext uri="{C572A759-6A51-4108-AA02-DFA0A04FC94B}">
-              <ma14:wrappingTextBoxFlag xmlns:ma14="http://schemas.microsoft.com/office/mac/drawingml/2011/main" xmlns="" val="0"/>
+              <ma14:wrappingTextBoxFlag xmlns="" xmlns:ma14="http://schemas.microsoft.com/office/mac/drawingml/2011/main" val="0"/>
             </a:ext>
           </a:extLst>
         </p:spPr>
@@ -8555,6 +8823,39 @@
               <a:t>2</a:t>
             </a:fld>
             <a:endParaRPr lang="en-US"/>
+          </a:p>
+        </p:txBody>
+      </p:sp>
+      <p:sp>
+        <p:nvSpPr>
+          <p:cNvPr id="26" name="Miks hind on võimalik"/>
+          <p:cNvSpPr txBox="1"/>
+          <p:nvPr/>
+        </p:nvSpPr>
+        <p:spPr>
+          <a:xfrm>
+            <a:off x="548640" y="987552"/>
+            <a:ext cx="11064240" cy="365760"/>
+          </a:xfrm>
+          <a:prstGeom prst="rect">
+            <a:avLst/>
+          </a:prstGeom>
+          <a:noFill/>
+        </p:spPr>
+        <p:txBody>
+          <a:bodyPr wrap="square" lIns="0" tIns="0" rIns="0" bIns="0"/>
+          <a:lstStyle/>
+          <a:p>
+            <a:pPr algn="l"/>
+            <a:r>
+              <a:rPr sz="1700">
+                <a:solidFill>
+                  <a:srgbClr val="5A6F8C"/>
+                </a:solidFill>
+                <a:latin typeface="Roboto"/>
+              </a:rPr>
+              <a:t>Kogumi hind on madal, sest tuhat inimest küsib korraga ja keegi ei teeni sellest, et sa üle maksad.</a:t>
+            </a:r>
           </a:p>
         </p:txBody>
       </p:sp>
@@ -8608,7 +8909,7 @@
         </p:blipFill>
         <p:spPr>
           <a:xfrm>
-            <a:off x="975208" y="502920"/>
+            <a:off x="988087" y="502920"/>
             <a:ext cx="10241280" cy="5760720"/>
           </a:xfrm>
           <a:prstGeom prst="rect">
@@ -9193,7 +9494,7 @@
           </a:prstGeom>
           <a:extLst>
             <a:ext uri="{C572A759-6A51-4108-AA02-DFA0A04FC94B}">
-              <ma14:wrappingTextBoxFlag xmlns:ma14="http://schemas.microsoft.com/office/mac/drawingml/2011/main" xmlns="" val="0"/>
+              <ma14:wrappingTextBoxFlag xmlns="" xmlns:ma14="http://schemas.microsoft.com/office/mac/drawingml/2011/main" val="0"/>
             </a:ext>
           </a:extLst>
         </p:spPr>
@@ -9915,7 +10216,7 @@
           </a:prstGeom>
           <a:extLst>
             <a:ext uri="{C572A759-6A51-4108-AA02-DFA0A04FC94B}">
-              <ma14:wrappingTextBoxFlag xmlns:ma14="http://schemas.microsoft.com/office/mac/drawingml/2011/main" xmlns="" val="0"/>
+              <ma14:wrappingTextBoxFlag xmlns="" xmlns:ma14="http://schemas.microsoft.com/office/mac/drawingml/2011/main" val="0"/>
             </a:ext>
           </a:extLst>
         </p:spPr>
@@ -10633,7 +10934,7 @@
           </a:prstGeom>
           <a:extLst>
             <a:ext uri="{C572A759-6A51-4108-AA02-DFA0A04FC94B}">
-              <ma14:wrappingTextBoxFlag xmlns:ma14="http://schemas.microsoft.com/office/mac/drawingml/2011/main" xmlns="" val="0"/>
+              <ma14:wrappingTextBoxFlag xmlns="" xmlns:ma14="http://schemas.microsoft.com/office/mac/drawingml/2011/main" val="0"/>
             </a:ext>
           </a:extLst>
         </p:spPr>
@@ -11169,7 +11470,7 @@
                 <a:ea typeface="Roboto" pitchFamily="34" charset="-122"/>
                 <a:cs typeface="Roboto" pitchFamily="34" charset="-120"/>
               </a:rPr>
-              <a:t>otsust</a:t>
+              <a:t>toetust</a:t>
             </a:r>
             <a:r>
               <a:rPr lang="en-US" sz="1700" dirty="0">
@@ -11648,7 +11949,7 @@
           </a:prstGeom>
           <a:extLst>
             <a:ext uri="{C572A759-6A51-4108-AA02-DFA0A04FC94B}">
-              <ma14:wrappingTextBoxFlag xmlns:ma14="http://schemas.microsoft.com/office/mac/drawingml/2011/main" xmlns="" val="0"/>
+              <ma14:wrappingTextBoxFlag xmlns="" xmlns:ma14="http://schemas.microsoft.com/office/mac/drawingml/2011/main" val="0"/>
             </a:ext>
           </a:extLst>
         </p:spPr>
@@ -13430,7 +13731,7 @@
           </a:prstGeom>
           <a:extLst>
             <a:ext uri="{C572A759-6A51-4108-AA02-DFA0A04FC94B}">
-              <ma14:wrappingTextBoxFlag xmlns:ma14="http://schemas.microsoft.com/office/mac/drawingml/2011/main" xmlns="" val="0"/>
+              <ma14:wrappingTextBoxFlag xmlns="" xmlns:ma14="http://schemas.microsoft.com/office/mac/drawingml/2011/main" val="0"/>
             </a:ext>
           </a:extLst>
         </p:spPr>

</xml_diff>